<commit_message>
20260721 commit : early finished, today
</commit_message>
<xml_diff>
--- a/ppt, excel, script/내거 모음/발표자료(주요 함수).pptx
+++ b/ppt, excel, script/내거 모음/발표자료(주요 함수).pptx
@@ -16,20 +16,24 @@
   <p:notesSz cx="6858000" cy="9144000"/>
   <p:embeddedFontLst>
     <p:embeddedFont>
-      <p:font typeface="Poppins Black" panose="020B0600000101010101" charset="0"/>
+      <p:font typeface="나눔스퀘어_ac Bold" panose="020B0600000101010101" pitchFamily="50" charset="-127"/>
       <p:bold r:id="rId6"/>
-      <p:boldItalic r:id="rId7"/>
     </p:embeddedFont>
     <p:embeddedFont>
-      <p:font typeface="나눔스퀘어_ac Bold" panose="020B0600000101010101" pitchFamily="50" charset="-127"/>
+      <p:font typeface="나눔스퀘어_ac" panose="020B0600000101010101" pitchFamily="50" charset="-127"/>
+      <p:regular r:id="rId7"/>
+    </p:embeddedFont>
+    <p:embeddedFont>
+      <p:font typeface="Poppins Black" panose="020B0600000101010101" charset="0"/>
       <p:bold r:id="rId8"/>
+      <p:boldItalic r:id="rId9"/>
     </p:embeddedFont>
     <p:embeddedFont>
       <p:font typeface="Calibri" panose="020F0502020204030204" pitchFamily="34" charset="0"/>
-      <p:regular r:id="rId9"/>
-      <p:bold r:id="rId10"/>
-      <p:italic r:id="rId11"/>
-      <p:boldItalic r:id="rId12"/>
+      <p:regular r:id="rId10"/>
+      <p:bold r:id="rId11"/>
+      <p:italic r:id="rId12"/>
+      <p:boldItalic r:id="rId13"/>
     </p:embeddedFont>
   </p:embeddedFontLst>
   <p:defaultTextStyle>
@@ -8663,7 +8667,7 @@
         <p:spPr>
           <a:xfrm>
             <a:off x="897794" y="2718566"/>
-            <a:ext cx="4076757" cy="830997"/>
+            <a:ext cx="3539752" cy="830997"/>
           </a:xfrm>
           <a:prstGeom prst="rect">
             <a:avLst/>
@@ -8677,44 +8681,77 @@
           <a:lstStyle/>
           <a:p>
             <a:r>
-              <a:rPr lang="ko-KR" altLang="en-US" sz="1600" dirty="0" smtClean="0"/>
+              <a:rPr lang="ko-KR" altLang="en-US" sz="1600" dirty="0" smtClean="0">
+                <a:latin typeface="나눔스퀘어_ac" panose="020B0600000101010101" pitchFamily="50" charset="-127"/>
+                <a:ea typeface="나눔스퀘어_ac" panose="020B0600000101010101" pitchFamily="50" charset="-127"/>
+              </a:rPr>
               <a:t>회원가입 시 하나의 회원 객체</a:t>
             </a:r>
             <a:r>
-              <a:rPr lang="en-US" altLang="ko-KR" sz="1600" dirty="0" smtClean="0"/>
+              <a:rPr lang="en-US" altLang="ko-KR" sz="1600" dirty="0" smtClean="0">
+                <a:latin typeface="나눔스퀘어_ac" panose="020B0600000101010101" pitchFamily="50" charset="-127"/>
+                <a:ea typeface="나눔스퀘어_ac" panose="020B0600000101010101" pitchFamily="50" charset="-127"/>
+              </a:rPr>
               <a:t>(JSON)</a:t>
             </a:r>
             <a:r>
-              <a:rPr lang="ko-KR" altLang="en-US" sz="1600" dirty="0" smtClean="0"/>
+              <a:rPr lang="ko-KR" altLang="en-US" sz="1600" dirty="0" smtClean="0">
+                <a:latin typeface="나눔스퀘어_ac" panose="020B0600000101010101" pitchFamily="50" charset="-127"/>
+                <a:ea typeface="나눔스퀘어_ac" panose="020B0600000101010101" pitchFamily="50" charset="-127"/>
+              </a:rPr>
               <a:t>를 </a:t>
             </a:r>
-            <a:endParaRPr lang="en-US" altLang="ko-KR" sz="1600" dirty="0" smtClean="0"/>
+            <a:endParaRPr lang="en-US" altLang="ko-KR" sz="1600" dirty="0" smtClean="0">
+              <a:latin typeface="나눔스퀘어_ac" panose="020B0600000101010101" pitchFamily="50" charset="-127"/>
+              <a:ea typeface="나눔스퀘어_ac" panose="020B0600000101010101" pitchFamily="50" charset="-127"/>
+            </a:endParaRPr>
           </a:p>
           <a:p>
             <a:r>
-              <a:rPr lang="ko-KR" altLang="en-US" sz="1600" dirty="0" smtClean="0"/>
+              <a:rPr lang="ko-KR" altLang="en-US" sz="1600" dirty="0" smtClean="0">
+                <a:latin typeface="나눔스퀘어_ac" panose="020B0600000101010101" pitchFamily="50" charset="-127"/>
+                <a:ea typeface="나눔스퀘어_ac" panose="020B0600000101010101" pitchFamily="50" charset="-127"/>
+              </a:rPr>
               <a:t>생성하면서</a:t>
             </a:r>
             <a:r>
-              <a:rPr lang="en-US" altLang="ko-KR" sz="1600" dirty="0" smtClean="0"/>
+              <a:rPr lang="en-US" altLang="ko-KR" sz="1600" dirty="0" smtClean="0">
+                <a:latin typeface="나눔스퀘어_ac" panose="020B0600000101010101" pitchFamily="50" charset="-127"/>
+                <a:ea typeface="나눔스퀘어_ac" panose="020B0600000101010101" pitchFamily="50" charset="-127"/>
+              </a:rPr>
               <a:t>, </a:t>
             </a:r>
             <a:r>
-              <a:rPr lang="ko-KR" altLang="en-US" sz="1600" dirty="0" smtClean="0"/>
+              <a:rPr lang="ko-KR" altLang="en-US" sz="1600" dirty="0" smtClean="0">
+                <a:latin typeface="나눔스퀘어_ac" panose="020B0600000101010101" pitchFamily="50" charset="-127"/>
+                <a:ea typeface="나눔스퀘어_ac" panose="020B0600000101010101" pitchFamily="50" charset="-127"/>
+              </a:rPr>
               <a:t>선택한 </a:t>
             </a:r>
             <a:r>
-              <a:rPr lang="ko-KR" altLang="en-US" sz="1600" dirty="0"/>
+              <a:rPr lang="ko-KR" altLang="en-US" sz="1600" dirty="0">
+                <a:latin typeface="나눔스퀘어_ac" panose="020B0600000101010101" pitchFamily="50" charset="-127"/>
+                <a:ea typeface="나눔스퀘어_ac" panose="020B0600000101010101" pitchFamily="50" charset="-127"/>
+              </a:rPr>
               <a:t>역할에 따라 권한 목록 </a:t>
             </a:r>
-            <a:endParaRPr lang="en-US" altLang="ko-KR" sz="1600" dirty="0" smtClean="0"/>
+            <a:endParaRPr lang="en-US" altLang="ko-KR" sz="1600" dirty="0" smtClean="0">
+              <a:latin typeface="나눔스퀘어_ac" panose="020B0600000101010101" pitchFamily="50" charset="-127"/>
+              <a:ea typeface="나눔스퀘어_ac" panose="020B0600000101010101" pitchFamily="50" charset="-127"/>
+            </a:endParaRPr>
           </a:p>
           <a:p>
             <a:r>
-              <a:rPr lang="ko-KR" altLang="en-US" sz="1600" dirty="0" smtClean="0"/>
+              <a:rPr lang="ko-KR" altLang="en-US" sz="1600" dirty="0" smtClean="0">
+                <a:latin typeface="나눔스퀘어_ac" panose="020B0600000101010101" pitchFamily="50" charset="-127"/>
+                <a:ea typeface="나눔스퀘어_ac" panose="020B0600000101010101" pitchFamily="50" charset="-127"/>
+              </a:rPr>
               <a:t>생성</a:t>
             </a:r>
-            <a:endParaRPr lang="ko-KR" altLang="en-US" sz="1600" dirty="0"/>
+            <a:endParaRPr lang="ko-KR" altLang="en-US" sz="1600" dirty="0">
+              <a:latin typeface="나눔스퀘어_ac" panose="020B0600000101010101" pitchFamily="50" charset="-127"/>
+              <a:ea typeface="나눔스퀘어_ac" panose="020B0600000101010101" pitchFamily="50" charset="-127"/>
+            </a:endParaRPr>
           </a:p>
         </p:txBody>
       </p:sp>
@@ -8808,7 +8845,7 @@
         <p:spPr>
           <a:xfrm>
             <a:off x="895161" y="4920766"/>
-            <a:ext cx="4281941" cy="338554"/>
+            <a:ext cx="3716082" cy="338554"/>
           </a:xfrm>
           <a:prstGeom prst="rect">
             <a:avLst/>
@@ -8822,26 +8859,44 @@
           <a:lstStyle/>
           <a:p>
             <a:r>
-              <a:rPr lang="ko-KR" altLang="en-US" sz="1600" dirty="0" smtClean="0"/>
+              <a:rPr lang="ko-KR" altLang="en-US" sz="1600" dirty="0" smtClean="0">
+                <a:latin typeface="나눔스퀘어_ac" panose="020B0600000101010101" pitchFamily="50" charset="-127"/>
+                <a:ea typeface="나눔스퀘어_ac" panose="020B0600000101010101" pitchFamily="50" charset="-127"/>
+              </a:rPr>
               <a:t>특정 </a:t>
             </a:r>
             <a:r>
-              <a:rPr lang="ko-KR" altLang="en-US" sz="1600" dirty="0"/>
+              <a:rPr lang="ko-KR" altLang="en-US" sz="1600" dirty="0">
+                <a:latin typeface="나눔스퀘어_ac" panose="020B0600000101010101" pitchFamily="50" charset="-127"/>
+                <a:ea typeface="나눔스퀘어_ac" panose="020B0600000101010101" pitchFamily="50" charset="-127"/>
+              </a:rPr>
               <a:t>계</a:t>
             </a:r>
             <a:r>
-              <a:rPr lang="ko-KR" altLang="en-US" sz="1600" dirty="0" smtClean="0"/>
+              <a:rPr lang="ko-KR" altLang="en-US" sz="1600" dirty="0" smtClean="0">
+                <a:latin typeface="나눔스퀘어_ac" panose="020B0600000101010101" pitchFamily="50" charset="-127"/>
+                <a:ea typeface="나눔스퀘어_ac" panose="020B0600000101010101" pitchFamily="50" charset="-127"/>
+              </a:rPr>
               <a:t>정에 권한을 추가하고</a:t>
             </a:r>
             <a:r>
-              <a:rPr lang="en-US" altLang="ko-KR" sz="1600" dirty="0" smtClean="0"/>
+              <a:rPr lang="en-US" altLang="ko-KR" sz="1600" dirty="0" smtClean="0">
+                <a:latin typeface="나눔스퀘어_ac" panose="020B0600000101010101" pitchFamily="50" charset="-127"/>
+                <a:ea typeface="나눔스퀘어_ac" panose="020B0600000101010101" pitchFamily="50" charset="-127"/>
+              </a:rPr>
               <a:t>, </a:t>
             </a:r>
             <a:r>
-              <a:rPr lang="ko-KR" altLang="en-US" sz="1600" dirty="0" smtClean="0"/>
+              <a:rPr lang="ko-KR" altLang="en-US" sz="1600" dirty="0" smtClean="0">
+                <a:latin typeface="나눔스퀘어_ac" panose="020B0600000101010101" pitchFamily="50" charset="-127"/>
+                <a:ea typeface="나눔스퀘어_ac" panose="020B0600000101010101" pitchFamily="50" charset="-127"/>
+              </a:rPr>
               <a:t>중복 추가 않음</a:t>
             </a:r>
-            <a:endParaRPr lang="ko-KR" altLang="en-US" sz="1600" dirty="0"/>
+            <a:endParaRPr lang="ko-KR" altLang="en-US" sz="1600" dirty="0">
+              <a:latin typeface="나눔스퀘어_ac" panose="020B0600000101010101" pitchFamily="50" charset="-127"/>
+              <a:ea typeface="나눔스퀘어_ac" panose="020B0600000101010101" pitchFamily="50" charset="-127"/>
+            </a:endParaRPr>
           </a:p>
         </p:txBody>
       </p:sp>
@@ -8981,7 +9036,7 @@
         <p:spPr>
           <a:xfrm>
             <a:off x="6463189" y="2613867"/>
-            <a:ext cx="4782078" cy="338554"/>
+            <a:ext cx="4144083" cy="338554"/>
           </a:xfrm>
           <a:prstGeom prst="rect">
             <a:avLst/>
@@ -8995,10 +9050,16 @@
           <a:lstStyle/>
           <a:p>
             <a:r>
-              <a:rPr lang="ko-KR" altLang="en-US" sz="1600" dirty="0" smtClean="0"/>
+              <a:rPr lang="ko-KR" altLang="en-US" sz="1600" dirty="0" smtClean="0">
+                <a:latin typeface="나눔스퀘어_ac" panose="020B0600000101010101" pitchFamily="50" charset="-127"/>
+                <a:ea typeface="나눔스퀘어_ac" panose="020B0600000101010101" pitchFamily="50" charset="-127"/>
+              </a:rPr>
               <a:t>카메라 영상을 실시간으로 읽는 백그라운드 스레드</a:t>
             </a:r>
-            <a:endParaRPr lang="ko-KR" altLang="en-US" sz="1600" dirty="0"/>
+            <a:endParaRPr lang="ko-KR" altLang="en-US" sz="1600" dirty="0">
+              <a:latin typeface="나눔스퀘어_ac" panose="020B0600000101010101" pitchFamily="50" charset="-127"/>
+              <a:ea typeface="나눔스퀘어_ac" panose="020B0600000101010101" pitchFamily="50" charset="-127"/>
+            </a:endParaRPr>
           </a:p>
         </p:txBody>
       </p:sp>
@@ -9099,7 +9160,7 @@
         <p:spPr>
           <a:xfrm>
             <a:off x="6464165" y="4100562"/>
-            <a:ext cx="3698448" cy="338554"/>
+            <a:ext cx="3286477" cy="338554"/>
           </a:xfrm>
           <a:prstGeom prst="rect">
             <a:avLst/>
@@ -9113,14 +9174,23 @@
           <a:lstStyle/>
           <a:p>
             <a:r>
-              <a:rPr lang="en-US" altLang="ko-KR" sz="1600" dirty="0" smtClean="0"/>
+              <a:rPr lang="en-US" altLang="ko-KR" sz="1600" dirty="0" smtClean="0">
+                <a:latin typeface="나눔스퀘어_ac" panose="020B0600000101010101" pitchFamily="50" charset="-127"/>
+                <a:ea typeface="나눔스퀘어_ac" panose="020B0600000101010101" pitchFamily="50" charset="-127"/>
+              </a:rPr>
               <a:t>Queue</a:t>
             </a:r>
             <a:r>
-              <a:rPr lang="ko-KR" altLang="en-US" sz="1600" dirty="0" smtClean="0"/>
+              <a:rPr lang="ko-KR" altLang="en-US" sz="1600" dirty="0" smtClean="0">
+                <a:latin typeface="나눔스퀘어_ac" panose="020B0600000101010101" pitchFamily="50" charset="-127"/>
+                <a:ea typeface="나눔스퀘어_ac" panose="020B0600000101010101" pitchFamily="50" charset="-127"/>
+              </a:rPr>
               <a:t>에서 최신 프레임을 하나씩 반환</a:t>
             </a:r>
-            <a:endParaRPr lang="ko-KR" altLang="en-US" sz="1600" dirty="0"/>
+            <a:endParaRPr lang="ko-KR" altLang="en-US" sz="1600" dirty="0">
+              <a:latin typeface="나눔스퀘어_ac" panose="020B0600000101010101" pitchFamily="50" charset="-127"/>
+              <a:ea typeface="나눔스퀘어_ac" panose="020B0600000101010101" pitchFamily="50" charset="-127"/>
+            </a:endParaRPr>
           </a:p>
         </p:txBody>
       </p:sp>
@@ -9133,7 +9203,7 @@
         <p:spPr>
           <a:xfrm>
             <a:off x="6463189" y="5575179"/>
-            <a:ext cx="5044971" cy="338554"/>
+            <a:ext cx="4371710" cy="338554"/>
           </a:xfrm>
           <a:prstGeom prst="rect">
             <a:avLst/>
@@ -9146,15 +9216,24 @@
           <a:lstStyle/>
           <a:p>
             <a:r>
-              <a:rPr lang="ko-KR" altLang="en-US" sz="1600" dirty="0"/>
+              <a:rPr lang="ko-KR" altLang="en-US" sz="1600" dirty="0">
+                <a:latin typeface="나눔스퀘어_ac" panose="020B0600000101010101" pitchFamily="50" charset="-127"/>
+                <a:ea typeface="나눔스퀘어_ac" panose="020B0600000101010101" pitchFamily="50" charset="-127"/>
+              </a:rPr>
               <a:t>동영상 스레드를 완전히 종료하고 </a:t>
             </a:r>
             <a:r>
-              <a:rPr lang="ko-KR" altLang="en-US" sz="1600" dirty="0" smtClean="0"/>
+              <a:rPr lang="ko-KR" altLang="en-US" sz="1600" dirty="0" smtClean="0">
+                <a:latin typeface="나눔스퀘어_ac" panose="020B0600000101010101" pitchFamily="50" charset="-127"/>
+                <a:ea typeface="나눔스퀘어_ac" panose="020B0600000101010101" pitchFamily="50" charset="-127"/>
+              </a:rPr>
               <a:t>비디오 </a:t>
             </a:r>
             <a:r>
-              <a:rPr lang="ko-KR" altLang="en-US" sz="1600" dirty="0"/>
+              <a:rPr lang="ko-KR" altLang="en-US" sz="1600" dirty="0">
+                <a:latin typeface="나눔스퀘어_ac" panose="020B0600000101010101" pitchFamily="50" charset="-127"/>
+                <a:ea typeface="나눔스퀘어_ac" panose="020B0600000101010101" pitchFamily="50" charset="-127"/>
+              </a:rPr>
               <a:t>자원을 해제</a:t>
             </a:r>
           </a:p>
@@ -9797,7 +9876,7 @@
         <p:spPr>
           <a:xfrm>
             <a:off x="897794" y="2718566"/>
-            <a:ext cx="5083443" cy="584775"/>
+            <a:ext cx="4435830" cy="584775"/>
           </a:xfrm>
           <a:prstGeom prst="rect">
             <a:avLst/>
@@ -9811,53 +9890,89 @@
           <a:lstStyle/>
           <a:p>
             <a:r>
-              <a:rPr lang="en-US" altLang="ko-KR" sz="1600" dirty="0"/>
+              <a:rPr lang="en-US" altLang="ko-KR" sz="1600" dirty="0">
+                <a:latin typeface="나눔스퀘어_ac" panose="020B0600000101010101" pitchFamily="50" charset="-127"/>
+                <a:ea typeface="나눔스퀘어_ac" panose="020B0600000101010101" pitchFamily="50" charset="-127"/>
+              </a:rPr>
               <a:t>YOLO </a:t>
             </a:r>
             <a:r>
-              <a:rPr lang="ko-KR" altLang="en-US" sz="1600" dirty="0"/>
+              <a:rPr lang="ko-KR" altLang="en-US" sz="1600" dirty="0">
+                <a:latin typeface="나눔스퀘어_ac" panose="020B0600000101010101" pitchFamily="50" charset="-127"/>
+                <a:ea typeface="나눔스퀘어_ac" panose="020B0600000101010101" pitchFamily="50" charset="-127"/>
+              </a:rPr>
               <a:t>객체 탐지</a:t>
             </a:r>
             <a:r>
-              <a:rPr lang="en-US" altLang="ko-KR" sz="1600" dirty="0"/>
+              <a:rPr lang="en-US" altLang="ko-KR" sz="1600" dirty="0">
+                <a:latin typeface="나눔스퀘어_ac" panose="020B0600000101010101" pitchFamily="50" charset="-127"/>
+                <a:ea typeface="나눔스퀘어_ac" panose="020B0600000101010101" pitchFamily="50" charset="-127"/>
+              </a:rPr>
               <a:t>, </a:t>
             </a:r>
             <a:r>
-              <a:rPr lang="ko-KR" altLang="en-US" sz="1600" dirty="0"/>
+              <a:rPr lang="ko-KR" altLang="en-US" sz="1600" dirty="0">
+                <a:latin typeface="나눔스퀘어_ac" panose="020B0600000101010101" pitchFamily="50" charset="-127"/>
+                <a:ea typeface="나눔스퀘어_ac" panose="020B0600000101010101" pitchFamily="50" charset="-127"/>
+              </a:rPr>
               <a:t>비동기 얼굴인식</a:t>
             </a:r>
             <a:r>
-              <a:rPr lang="en-US" altLang="ko-KR" sz="1600" dirty="0"/>
+              <a:rPr lang="en-US" altLang="ko-KR" sz="1600" dirty="0">
+                <a:latin typeface="나눔스퀘어_ac" panose="020B0600000101010101" pitchFamily="50" charset="-127"/>
+                <a:ea typeface="나눔스퀘어_ac" panose="020B0600000101010101" pitchFamily="50" charset="-127"/>
+              </a:rPr>
               <a:t>, </a:t>
             </a:r>
             <a:r>
-              <a:rPr lang="ko-KR" altLang="en-US" sz="1600" dirty="0"/>
+              <a:rPr lang="ko-KR" altLang="en-US" sz="1600" dirty="0">
+                <a:latin typeface="나눔스퀘어_ac" panose="020B0600000101010101" pitchFamily="50" charset="-127"/>
+                <a:ea typeface="나눔스퀘어_ac" panose="020B0600000101010101" pitchFamily="50" charset="-127"/>
+              </a:rPr>
               <a:t>재인식 주기 제어</a:t>
             </a:r>
             <a:r>
-              <a:rPr lang="en-US" altLang="ko-KR" sz="1600" dirty="0"/>
+              <a:rPr lang="en-US" altLang="ko-KR" sz="1600" dirty="0">
+                <a:latin typeface="나눔스퀘어_ac" panose="020B0600000101010101" pitchFamily="50" charset="-127"/>
+                <a:ea typeface="나눔스퀘어_ac" panose="020B0600000101010101" pitchFamily="50" charset="-127"/>
+              </a:rPr>
               <a:t>, </a:t>
             </a:r>
           </a:p>
           <a:p>
             <a:r>
-              <a:rPr lang="ko-KR" altLang="en-US" sz="1600" dirty="0"/>
+              <a:rPr lang="ko-KR" altLang="en-US" sz="1600" dirty="0">
+                <a:latin typeface="나눔스퀘어_ac" panose="020B0600000101010101" pitchFamily="50" charset="-127"/>
+                <a:ea typeface="나눔스퀘어_ac" panose="020B0600000101010101" pitchFamily="50" charset="-127"/>
+              </a:rPr>
               <a:t>중복 요청 방지</a:t>
             </a:r>
             <a:r>
-              <a:rPr lang="en-US" altLang="ko-KR" sz="1600" dirty="0"/>
+              <a:rPr lang="en-US" altLang="ko-KR" sz="1600" dirty="0">
+                <a:latin typeface="나눔스퀘어_ac" panose="020B0600000101010101" pitchFamily="50" charset="-127"/>
+                <a:ea typeface="나눔스퀘어_ac" panose="020B0600000101010101" pitchFamily="50" charset="-127"/>
+              </a:rPr>
               <a:t>, </a:t>
             </a:r>
             <a:r>
-              <a:rPr lang="ko-KR" altLang="en-US" sz="1600" dirty="0"/>
+              <a:rPr lang="ko-KR" altLang="en-US" sz="1600" dirty="0">
+                <a:latin typeface="나눔스퀘어_ac" panose="020B0600000101010101" pitchFamily="50" charset="-127"/>
+                <a:ea typeface="나눔스퀘어_ac" panose="020B0600000101010101" pitchFamily="50" charset="-127"/>
+              </a:rPr>
               <a:t>실시간 이벤트 생성</a:t>
             </a:r>
             <a:r>
-              <a:rPr lang="en-US" altLang="ko-KR" sz="1600" dirty="0"/>
+              <a:rPr lang="en-US" altLang="ko-KR" sz="1600" dirty="0">
+                <a:latin typeface="나눔스퀘어_ac" panose="020B0600000101010101" pitchFamily="50" charset="-127"/>
+                <a:ea typeface="나눔스퀘어_ac" panose="020B0600000101010101" pitchFamily="50" charset="-127"/>
+              </a:rPr>
               <a:t>, </a:t>
             </a:r>
             <a:r>
-              <a:rPr lang="ko-KR" altLang="en-US" sz="1600" dirty="0"/>
+              <a:rPr lang="ko-KR" altLang="en-US" sz="1600" dirty="0">
+                <a:latin typeface="나눔스퀘어_ac" panose="020B0600000101010101" pitchFamily="50" charset="-127"/>
+                <a:ea typeface="나눔스퀘어_ac" panose="020B0600000101010101" pitchFamily="50" charset="-127"/>
+              </a:rPr>
               <a:t>메모리 관리</a:t>
             </a:r>
           </a:p>
@@ -9946,7 +10061,7 @@
         <p:spPr>
           <a:xfrm>
             <a:off x="895161" y="4920766"/>
-            <a:ext cx="4775666" cy="584775"/>
+            <a:ext cx="4145687" cy="584775"/>
           </a:xfrm>
           <a:prstGeom prst="rect">
             <a:avLst/>
@@ -9960,64 +10075,109 @@
           <a:lstStyle/>
           <a:p>
             <a:r>
-              <a:rPr lang="ko-KR" altLang="en-US" sz="1600" dirty="0"/>
+              <a:rPr lang="ko-KR" altLang="en-US" sz="1600" dirty="0">
+                <a:latin typeface="나눔스퀘어_ac" panose="020B0600000101010101" pitchFamily="50" charset="-127"/>
+                <a:ea typeface="나눔스퀘어_ac" panose="020B0600000101010101" pitchFamily="50" charset="-127"/>
+              </a:rPr>
               <a:t>얼굴 특징 추출</a:t>
             </a:r>
             <a:r>
-              <a:rPr lang="en-US" altLang="ko-KR" sz="1600" dirty="0"/>
+              <a:rPr lang="en-US" altLang="ko-KR" sz="1600" dirty="0">
+                <a:latin typeface="나눔스퀘어_ac" panose="020B0600000101010101" pitchFamily="50" charset="-127"/>
+                <a:ea typeface="나눔스퀘어_ac" panose="020B0600000101010101" pitchFamily="50" charset="-127"/>
+              </a:rPr>
               <a:t>, </a:t>
             </a:r>
             <a:r>
-              <a:rPr lang="ko-KR" altLang="en-US" sz="1600" dirty="0"/>
+              <a:rPr lang="ko-KR" altLang="en-US" sz="1600" dirty="0">
+                <a:latin typeface="나눔스퀘어_ac" panose="020B0600000101010101" pitchFamily="50" charset="-127"/>
+                <a:ea typeface="나눔스퀘어_ac" panose="020B0600000101010101" pitchFamily="50" charset="-127"/>
+              </a:rPr>
               <a:t>얼굴 특징 비교</a:t>
             </a:r>
             <a:r>
-              <a:rPr lang="en-US" altLang="ko-KR" sz="1600" dirty="0"/>
+              <a:rPr lang="en-US" altLang="ko-KR" sz="1600" dirty="0">
+                <a:latin typeface="나눔스퀘어_ac" panose="020B0600000101010101" pitchFamily="50" charset="-127"/>
+                <a:ea typeface="나눔스퀘어_ac" panose="020B0600000101010101" pitchFamily="50" charset="-127"/>
+              </a:rPr>
               <a:t>, </a:t>
             </a:r>
             <a:r>
-              <a:rPr lang="ko-KR" altLang="en-US" sz="1600" dirty="0"/>
+              <a:rPr lang="ko-KR" altLang="en-US" sz="1600" dirty="0">
+                <a:latin typeface="나눔스퀘어_ac" panose="020B0600000101010101" pitchFamily="50" charset="-127"/>
+                <a:ea typeface="나눔스퀘어_ac" panose="020B0600000101010101" pitchFamily="50" charset="-127"/>
+              </a:rPr>
               <a:t>최고 유사도 선택</a:t>
             </a:r>
             <a:r>
-              <a:rPr lang="en-US" altLang="ko-KR" sz="1600" dirty="0"/>
+              <a:rPr lang="en-US" altLang="ko-KR" sz="1600" dirty="0">
+                <a:latin typeface="나눔스퀘어_ac" panose="020B0600000101010101" pitchFamily="50" charset="-127"/>
+                <a:ea typeface="나눔스퀘어_ac" panose="020B0600000101010101" pitchFamily="50" charset="-127"/>
+              </a:rPr>
               <a:t>, </a:t>
             </a:r>
           </a:p>
           <a:p>
             <a:r>
-              <a:rPr lang="en-US" altLang="ko-KR" sz="1600" dirty="0"/>
+              <a:rPr lang="en-US" altLang="ko-KR" sz="1600" dirty="0">
+                <a:latin typeface="나눔스퀘어_ac" panose="020B0600000101010101" pitchFamily="50" charset="-127"/>
+                <a:ea typeface="나눔스퀘어_ac" panose="020B0600000101010101" pitchFamily="50" charset="-127"/>
+              </a:rPr>
               <a:t>Threshold </a:t>
             </a:r>
             <a:r>
-              <a:rPr lang="ko-KR" altLang="en-US" sz="1600" dirty="0"/>
+              <a:rPr lang="ko-KR" altLang="en-US" sz="1600" dirty="0">
+                <a:latin typeface="나눔스퀘어_ac" panose="020B0600000101010101" pitchFamily="50" charset="-127"/>
+                <a:ea typeface="나눔스퀘어_ac" panose="020B0600000101010101" pitchFamily="50" charset="-127"/>
+              </a:rPr>
               <a:t>적용 </a:t>
             </a:r>
             <a:r>
-              <a:rPr lang="en-US" altLang="ko-KR" sz="1600" dirty="0"/>
+              <a:rPr lang="en-US" altLang="ko-KR" sz="1600" dirty="0">
+                <a:latin typeface="나눔스퀘어_ac" panose="020B0600000101010101" pitchFamily="50" charset="-127"/>
+                <a:ea typeface="나눔스퀘어_ac" panose="020B0600000101010101" pitchFamily="50" charset="-127"/>
+              </a:rPr>
               <a:t>&gt; </a:t>
             </a:r>
             <a:r>
-              <a:rPr lang="ko-KR" altLang="en-US" sz="1600" dirty="0" err="1"/>
+              <a:rPr lang="ko-KR" altLang="en-US" sz="1600" dirty="0" err="1">
+                <a:latin typeface="나눔스퀘어_ac" panose="020B0600000101010101" pitchFamily="50" charset="-127"/>
+                <a:ea typeface="나눔스퀘어_ac" panose="020B0600000101010101" pitchFamily="50" charset="-127"/>
+              </a:rPr>
               <a:t>임계치</a:t>
             </a:r>
             <a:r>
-              <a:rPr lang="ko-KR" altLang="en-US" sz="1600" dirty="0"/>
+              <a:rPr lang="ko-KR" altLang="en-US" sz="1600" dirty="0">
+                <a:latin typeface="나눔스퀘어_ac" panose="020B0600000101010101" pitchFamily="50" charset="-127"/>
+                <a:ea typeface="나눔스퀘어_ac" panose="020B0600000101010101" pitchFamily="50" charset="-127"/>
+              </a:rPr>
               <a:t> 미만은 </a:t>
             </a:r>
             <a:r>
-              <a:rPr lang="ko-KR" altLang="en-US" sz="1600" dirty="0" err="1"/>
+              <a:rPr lang="ko-KR" altLang="en-US" sz="1600" dirty="0" err="1">
+                <a:latin typeface="나눔스퀘어_ac" panose="020B0600000101010101" pitchFamily="50" charset="-127"/>
+                <a:ea typeface="나눔스퀘어_ac" panose="020B0600000101010101" pitchFamily="50" charset="-127"/>
+              </a:rPr>
               <a:t>미인식</a:t>
             </a:r>
             <a:r>
-              <a:rPr lang="ko-KR" altLang="en-US" sz="1600" dirty="0"/>
+              <a:rPr lang="ko-KR" altLang="en-US" sz="1600" dirty="0">
+                <a:latin typeface="나눔스퀘어_ac" panose="020B0600000101010101" pitchFamily="50" charset="-127"/>
+                <a:ea typeface="나눔스퀘어_ac" panose="020B0600000101010101" pitchFamily="50" charset="-127"/>
+              </a:rPr>
               <a:t> </a:t>
             </a:r>
             <a:r>
-              <a:rPr lang="ko-KR" altLang="en-US" sz="1600" dirty="0" smtClean="0"/>
+              <a:rPr lang="ko-KR" altLang="en-US" sz="1600" dirty="0" smtClean="0">
+                <a:latin typeface="나눔스퀘어_ac" panose="020B0600000101010101" pitchFamily="50" charset="-127"/>
+                <a:ea typeface="나눔스퀘어_ac" panose="020B0600000101010101" pitchFamily="50" charset="-127"/>
+              </a:rPr>
               <a:t>처리</a:t>
             </a:r>
-            <a:endParaRPr lang="ko-KR" altLang="en-US" sz="1600" dirty="0"/>
+            <a:endParaRPr lang="ko-KR" altLang="en-US" sz="1600" dirty="0">
+              <a:latin typeface="나눔스퀘어_ac" panose="020B0600000101010101" pitchFamily="50" charset="-127"/>
+              <a:ea typeface="나눔스퀘어_ac" panose="020B0600000101010101" pitchFamily="50" charset="-127"/>
+            </a:endParaRPr>
           </a:p>
         </p:txBody>
       </p:sp>
@@ -10111,7 +10271,7 @@
         <p:spPr>
           <a:xfrm>
             <a:off x="6470000" y="2721691"/>
-            <a:ext cx="4794902" cy="584775"/>
+            <a:ext cx="4209807" cy="584775"/>
           </a:xfrm>
           <a:prstGeom prst="rect">
             <a:avLst/>
@@ -10125,41 +10285,71 @@
           <a:lstStyle/>
           <a:p>
             <a:r>
-              <a:rPr lang="ko-KR" altLang="en-US" sz="1600" dirty="0"/>
+              <a:rPr lang="ko-KR" altLang="en-US" sz="1600" dirty="0">
+                <a:latin typeface="나눔스퀘어_ac" panose="020B0600000101010101" pitchFamily="50" charset="-127"/>
+                <a:ea typeface="나눔스퀘어_ac" panose="020B0600000101010101" pitchFamily="50" charset="-127"/>
+              </a:rPr>
               <a:t>이벤트 로그 생성</a:t>
             </a:r>
             <a:r>
-              <a:rPr lang="en-US" altLang="ko-KR" sz="1600" dirty="0"/>
+              <a:rPr lang="en-US" altLang="ko-KR" sz="1600" dirty="0">
+                <a:latin typeface="나눔스퀘어_ac" panose="020B0600000101010101" pitchFamily="50" charset="-127"/>
+                <a:ea typeface="나눔스퀘어_ac" panose="020B0600000101010101" pitchFamily="50" charset="-127"/>
+              </a:rPr>
               <a:t>, JSON </a:t>
             </a:r>
             <a:r>
-              <a:rPr lang="ko-KR" altLang="en-US" sz="1600" dirty="0"/>
+              <a:rPr lang="ko-KR" altLang="en-US" sz="1600" dirty="0">
+                <a:latin typeface="나눔스퀘어_ac" panose="020B0600000101010101" pitchFamily="50" charset="-127"/>
+                <a:ea typeface="나눔스퀘어_ac" panose="020B0600000101010101" pitchFamily="50" charset="-127"/>
+              </a:rPr>
               <a:t>저장</a:t>
             </a:r>
             <a:r>
-              <a:rPr lang="en-US" altLang="ko-KR" sz="1600" dirty="0"/>
+              <a:rPr lang="en-US" altLang="ko-KR" sz="1600" dirty="0">
+                <a:latin typeface="나눔스퀘어_ac" panose="020B0600000101010101" pitchFamily="50" charset="-127"/>
+                <a:ea typeface="나눔스퀘어_ac" panose="020B0600000101010101" pitchFamily="50" charset="-127"/>
+              </a:rPr>
               <a:t>, SSE </a:t>
             </a:r>
             <a:r>
-              <a:rPr lang="ko-KR" altLang="en-US" sz="1600" dirty="0"/>
+              <a:rPr lang="ko-KR" altLang="en-US" sz="1600" dirty="0">
+                <a:latin typeface="나눔스퀘어_ac" panose="020B0600000101010101" pitchFamily="50" charset="-127"/>
+                <a:ea typeface="나눔스퀘어_ac" panose="020B0600000101010101" pitchFamily="50" charset="-127"/>
+              </a:rPr>
               <a:t>웹으로</a:t>
             </a:r>
             <a:r>
-              <a:rPr lang="en-US" altLang="ko-KR" sz="1600" dirty="0"/>
+              <a:rPr lang="en-US" altLang="ko-KR" sz="1600" dirty="0">
+                <a:latin typeface="나눔스퀘어_ac" panose="020B0600000101010101" pitchFamily="50" charset="-127"/>
+                <a:ea typeface="나눔스퀘어_ac" panose="020B0600000101010101" pitchFamily="50" charset="-127"/>
+              </a:rPr>
               <a:t> </a:t>
             </a:r>
             <a:r>
-              <a:rPr lang="ko-KR" altLang="en-US" sz="1600" dirty="0"/>
+              <a:rPr lang="ko-KR" altLang="en-US" sz="1600" dirty="0">
+                <a:latin typeface="나눔스퀘어_ac" panose="020B0600000101010101" pitchFamily="50" charset="-127"/>
+                <a:ea typeface="나눔스퀘어_ac" panose="020B0600000101010101" pitchFamily="50" charset="-127"/>
+              </a:rPr>
               <a:t>실시간 </a:t>
             </a:r>
-            <a:endParaRPr lang="en-US" altLang="ko-KR" sz="1600" dirty="0" smtClean="0"/>
+            <a:endParaRPr lang="en-US" altLang="ko-KR" sz="1600" dirty="0" smtClean="0">
+              <a:latin typeface="나눔스퀘어_ac" panose="020B0600000101010101" pitchFamily="50" charset="-127"/>
+              <a:ea typeface="나눔스퀘어_ac" panose="020B0600000101010101" pitchFamily="50" charset="-127"/>
+            </a:endParaRPr>
           </a:p>
           <a:p>
             <a:r>
-              <a:rPr lang="ko-KR" altLang="en-US" sz="1600" dirty="0" smtClean="0"/>
+              <a:rPr lang="ko-KR" altLang="en-US" sz="1600" dirty="0" smtClean="0">
+                <a:latin typeface="나눔스퀘어_ac" panose="020B0600000101010101" pitchFamily="50" charset="-127"/>
+                <a:ea typeface="나눔스퀘어_ac" panose="020B0600000101010101" pitchFamily="50" charset="-127"/>
+              </a:rPr>
               <a:t>알림</a:t>
             </a:r>
-            <a:endParaRPr lang="ko-KR" altLang="en-US" sz="1600" dirty="0"/>
+            <a:endParaRPr lang="ko-KR" altLang="en-US" sz="1600" dirty="0">
+              <a:latin typeface="나눔스퀘어_ac" panose="020B0600000101010101" pitchFamily="50" charset="-127"/>
+              <a:ea typeface="나눔스퀘어_ac" panose="020B0600000101010101" pitchFamily="50" charset="-127"/>
+            </a:endParaRPr>
           </a:p>
         </p:txBody>
       </p:sp>
@@ -10253,7 +10443,7 @@
         <p:spPr>
           <a:xfrm>
             <a:off x="6467367" y="4923891"/>
-            <a:ext cx="4839786" cy="584775"/>
+            <a:ext cx="4373313" cy="584775"/>
           </a:xfrm>
           <a:prstGeom prst="rect">
             <a:avLst/>
@@ -10267,40 +10457,67 @@
           <a:lstStyle/>
           <a:p>
             <a:r>
-              <a:rPr lang="ko-KR" altLang="en-US" sz="1600" dirty="0"/>
+              <a:rPr lang="ko-KR" altLang="en-US" sz="1600" dirty="0">
+                <a:latin typeface="나눔스퀘어_ac" panose="020B0600000101010101" pitchFamily="50" charset="-127"/>
+                <a:ea typeface="나눔스퀘어_ac" panose="020B0600000101010101" pitchFamily="50" charset="-127"/>
+              </a:rPr>
               <a:t>브라우저에서 이벤트 수신</a:t>
             </a:r>
             <a:r>
-              <a:rPr lang="en-US" altLang="ko-KR" sz="1600" dirty="0"/>
+              <a:rPr lang="en-US" altLang="ko-KR" sz="1600" dirty="0">
+                <a:latin typeface="나눔스퀘어_ac" panose="020B0600000101010101" pitchFamily="50" charset="-127"/>
+                <a:ea typeface="나눔스퀘어_ac" panose="020B0600000101010101" pitchFamily="50" charset="-127"/>
+              </a:rPr>
               <a:t>, </a:t>
             </a:r>
             <a:r>
-              <a:rPr lang="en-US" altLang="ko-KR" sz="1600" dirty="0" err="1"/>
+              <a:rPr lang="en-US" altLang="ko-KR" sz="1600" dirty="0" err="1">
+                <a:latin typeface="나눔스퀘어_ac" panose="020B0600000101010101" pitchFamily="50" charset="-127"/>
+                <a:ea typeface="나눔스퀘어_ac" panose="020B0600000101010101" pitchFamily="50" charset="-127"/>
+              </a:rPr>
               <a:t>EventSource</a:t>
             </a:r>
             <a:r>
-              <a:rPr lang="en-US" altLang="ko-KR" sz="1600" dirty="0"/>
+              <a:rPr lang="en-US" altLang="ko-KR" sz="1600" dirty="0">
+                <a:latin typeface="나눔스퀘어_ac" panose="020B0600000101010101" pitchFamily="50" charset="-127"/>
+                <a:ea typeface="나눔스퀘어_ac" panose="020B0600000101010101" pitchFamily="50" charset="-127"/>
+              </a:rPr>
               <a:t> </a:t>
             </a:r>
             <a:r>
-              <a:rPr lang="ko-KR" altLang="en-US" sz="1600" dirty="0"/>
+              <a:rPr lang="ko-KR" altLang="en-US" sz="1600" dirty="0">
+                <a:latin typeface="나눔스퀘어_ac" panose="020B0600000101010101" pitchFamily="50" charset="-127"/>
+                <a:ea typeface="나눔스퀘어_ac" panose="020B0600000101010101" pitchFamily="50" charset="-127"/>
+              </a:rPr>
               <a:t>연결 유지</a:t>
             </a:r>
             <a:r>
-              <a:rPr lang="en-US" altLang="ko-KR" sz="1600" dirty="0"/>
+              <a:rPr lang="en-US" altLang="ko-KR" sz="1600" dirty="0">
+                <a:latin typeface="나눔스퀘어_ac" panose="020B0600000101010101" pitchFamily="50" charset="-127"/>
+                <a:ea typeface="나눔스퀘어_ac" panose="020B0600000101010101" pitchFamily="50" charset="-127"/>
+              </a:rPr>
               <a:t>,</a:t>
             </a:r>
           </a:p>
           <a:p>
             <a:r>
-              <a:rPr lang="ko-KR" altLang="en-US" sz="1600" dirty="0"/>
+              <a:rPr lang="ko-KR" altLang="en-US" sz="1600" dirty="0">
+                <a:latin typeface="나눔스퀘어_ac" panose="020B0600000101010101" pitchFamily="50" charset="-127"/>
+                <a:ea typeface="나눔스퀘어_ac" panose="020B0600000101010101" pitchFamily="50" charset="-127"/>
+              </a:rPr>
               <a:t>새 이벤트를 실시간 데이터로 </a:t>
             </a:r>
             <a:r>
-              <a:rPr lang="ko-KR" altLang="en-US" sz="1600" dirty="0" smtClean="0"/>
+              <a:rPr lang="ko-KR" altLang="en-US" sz="1600" dirty="0" smtClean="0">
+                <a:latin typeface="나눔스퀘어_ac" panose="020B0600000101010101" pitchFamily="50" charset="-127"/>
+                <a:ea typeface="나눔스퀘어_ac" panose="020B0600000101010101" pitchFamily="50" charset="-127"/>
+              </a:rPr>
               <a:t>수집</a:t>
             </a:r>
-            <a:endParaRPr lang="en-US" altLang="ko-KR" sz="1600" dirty="0"/>
+            <a:endParaRPr lang="en-US" altLang="ko-KR" sz="1600" dirty="0">
+              <a:latin typeface="나눔스퀘어_ac" panose="020B0600000101010101" pitchFamily="50" charset="-127"/>
+              <a:ea typeface="나눔스퀘어_ac" panose="020B0600000101010101" pitchFamily="50" charset="-127"/>
+            </a:endParaRPr>
           </a:p>
         </p:txBody>
       </p:sp>
@@ -10903,7 +11120,7 @@
         <p:spPr>
           <a:xfrm>
             <a:off x="897794" y="2718566"/>
-            <a:ext cx="4634602" cy="584775"/>
+            <a:ext cx="4019049" cy="584775"/>
           </a:xfrm>
           <a:prstGeom prst="rect">
             <a:avLst/>
@@ -10917,33 +11134,57 @@
           <a:lstStyle/>
           <a:p>
             <a:r>
-              <a:rPr lang="ko-KR" altLang="en-US" sz="1600" dirty="0"/>
+              <a:rPr lang="ko-KR" altLang="en-US" sz="1600" dirty="0">
+                <a:latin typeface="나눔스퀘어_ac" panose="020B0600000101010101" pitchFamily="50" charset="-127"/>
+                <a:ea typeface="나눔스퀘어_ac" panose="020B0600000101010101" pitchFamily="50" charset="-127"/>
+              </a:rPr>
               <a:t>대시보드의 전체 데이터를 통합해 하나의 객체로 </a:t>
             </a:r>
-            <a:endParaRPr lang="en-US" altLang="ko-KR" sz="1600" dirty="0" smtClean="0"/>
+            <a:endParaRPr lang="en-US" altLang="ko-KR" sz="1600" dirty="0" smtClean="0">
+              <a:latin typeface="나눔스퀘어_ac" panose="020B0600000101010101" pitchFamily="50" charset="-127"/>
+              <a:ea typeface="나눔스퀘어_ac" panose="020B0600000101010101" pitchFamily="50" charset="-127"/>
+            </a:endParaRPr>
           </a:p>
           <a:p>
             <a:r>
-              <a:rPr lang="ko-KR" altLang="en-US" sz="1600" dirty="0" smtClean="0"/>
+              <a:rPr lang="ko-KR" altLang="en-US" sz="1600" dirty="0" smtClean="0">
+                <a:latin typeface="나눔스퀘어_ac" panose="020B0600000101010101" pitchFamily="50" charset="-127"/>
+                <a:ea typeface="나눔스퀘어_ac" panose="020B0600000101010101" pitchFamily="50" charset="-127"/>
+              </a:rPr>
               <a:t>반환</a:t>
             </a:r>
             <a:r>
-              <a:rPr lang="en-US" altLang="ko-KR" sz="1600" dirty="0"/>
+              <a:rPr lang="en-US" altLang="ko-KR" sz="1600" dirty="0">
+                <a:latin typeface="나눔스퀘어_ac" panose="020B0600000101010101" pitchFamily="50" charset="-127"/>
+                <a:ea typeface="나눔스퀘어_ac" panose="020B0600000101010101" pitchFamily="50" charset="-127"/>
+              </a:rPr>
               <a:t>,</a:t>
             </a:r>
             <a:r>
-              <a:rPr lang="ko-KR" altLang="en-US" sz="1600" dirty="0"/>
+              <a:rPr lang="ko-KR" altLang="en-US" sz="1600" dirty="0">
+                <a:latin typeface="나눔스퀘어_ac" panose="020B0600000101010101" pitchFamily="50" charset="-127"/>
+                <a:ea typeface="나눔스퀘어_ac" panose="020B0600000101010101" pitchFamily="50" charset="-127"/>
+              </a:rPr>
               <a:t> </a:t>
             </a:r>
             <a:r>
-              <a:rPr lang="ko-KR" altLang="en-US" sz="1600" dirty="0" smtClean="0"/>
+              <a:rPr lang="ko-KR" altLang="en-US" sz="1600" dirty="0" smtClean="0">
+                <a:latin typeface="나눔스퀘어_ac" panose="020B0600000101010101" pitchFamily="50" charset="-127"/>
+                <a:ea typeface="나눔스퀘어_ac" panose="020B0600000101010101" pitchFamily="50" charset="-127"/>
+              </a:rPr>
               <a:t>실시간 </a:t>
             </a:r>
             <a:r>
-              <a:rPr lang="ko-KR" altLang="en-US" sz="1600" dirty="0"/>
+              <a:rPr lang="ko-KR" altLang="en-US" sz="1600" dirty="0">
+                <a:latin typeface="나눔스퀘어_ac" panose="020B0600000101010101" pitchFamily="50" charset="-127"/>
+                <a:ea typeface="나눔스퀘어_ac" panose="020B0600000101010101" pitchFamily="50" charset="-127"/>
+              </a:rPr>
               <a:t>집계</a:t>
             </a:r>
-            <a:endParaRPr lang="en-US" altLang="ko-KR" sz="1600" dirty="0"/>
+            <a:endParaRPr lang="en-US" altLang="ko-KR" sz="1600" dirty="0">
+              <a:latin typeface="나눔스퀘어_ac" panose="020B0600000101010101" pitchFamily="50" charset="-127"/>
+              <a:ea typeface="나눔스퀘어_ac" panose="020B0600000101010101" pitchFamily="50" charset="-127"/>
+            </a:endParaRPr>
           </a:p>
         </p:txBody>
       </p:sp>
@@ -11044,7 +11285,7 @@
         <p:spPr>
           <a:xfrm>
             <a:off x="895161" y="4920766"/>
-            <a:ext cx="3929281" cy="584775"/>
+            <a:ext cx="3427541" cy="584775"/>
           </a:xfrm>
           <a:prstGeom prst="rect">
             <a:avLst/>
@@ -11058,33 +11299,54 @@
           <a:lstStyle/>
           <a:p>
             <a:r>
-              <a:rPr lang="ko-KR" altLang="en-US" sz="1600" dirty="0"/>
+              <a:rPr lang="ko-KR" altLang="en-US" sz="1600" dirty="0">
+                <a:latin typeface="나눔스퀘어_ac" panose="020B0600000101010101" pitchFamily="50" charset="-127"/>
+                <a:ea typeface="나눔스퀘어_ac" panose="020B0600000101010101" pitchFamily="50" charset="-127"/>
+              </a:rPr>
               <a:t>최신 이벤트 생성</a:t>
             </a:r>
             <a:r>
-              <a:rPr lang="en-US" altLang="ko-KR" sz="1600" dirty="0"/>
+              <a:rPr lang="en-US" altLang="ko-KR" sz="1600" dirty="0">
+                <a:latin typeface="나눔스퀘어_ac" panose="020B0600000101010101" pitchFamily="50" charset="-127"/>
+                <a:ea typeface="나눔스퀘어_ac" panose="020B0600000101010101" pitchFamily="50" charset="-127"/>
+              </a:rPr>
               <a:t>, </a:t>
             </a:r>
             <a:r>
-              <a:rPr lang="ko-KR" altLang="en-US" sz="1600" dirty="0"/>
+              <a:rPr lang="ko-KR" altLang="en-US" sz="1600" dirty="0">
+                <a:latin typeface="나눔스퀘어_ac" panose="020B0600000101010101" pitchFamily="50" charset="-127"/>
+                <a:ea typeface="나눔스퀘어_ac" panose="020B0600000101010101" pitchFamily="50" charset="-127"/>
+              </a:rPr>
               <a:t>최신 이벤트 </a:t>
             </a:r>
             <a:r>
-              <a:rPr lang="en-US" altLang="ko-KR" sz="1600" dirty="0"/>
+              <a:rPr lang="en-US" altLang="ko-KR" sz="1600" dirty="0">
+                <a:latin typeface="나눔스퀘어_ac" panose="020B0600000101010101" pitchFamily="50" charset="-127"/>
+                <a:ea typeface="나눔스퀘어_ac" panose="020B0600000101010101" pitchFamily="50" charset="-127"/>
+              </a:rPr>
               <a:t>N</a:t>
             </a:r>
             <a:r>
-              <a:rPr lang="ko-KR" altLang="en-US" sz="1600" dirty="0"/>
+              <a:rPr lang="ko-KR" altLang="en-US" sz="1600" dirty="0">
+                <a:latin typeface="나눔스퀘어_ac" panose="020B0600000101010101" pitchFamily="50" charset="-127"/>
+                <a:ea typeface="나눔스퀘어_ac" panose="020B0600000101010101" pitchFamily="50" charset="-127"/>
+              </a:rPr>
               <a:t>개 추출</a:t>
             </a:r>
             <a:r>
-              <a:rPr lang="en-US" altLang="ko-KR" sz="1600" dirty="0"/>
+              <a:rPr lang="en-US" altLang="ko-KR" sz="1600" dirty="0">
+                <a:latin typeface="나눔스퀘어_ac" panose="020B0600000101010101" pitchFamily="50" charset="-127"/>
+                <a:ea typeface="나눔스퀘어_ac" panose="020B0600000101010101" pitchFamily="50" charset="-127"/>
+              </a:rPr>
               <a:t>, </a:t>
             </a:r>
           </a:p>
           <a:p>
             <a:r>
-              <a:rPr lang="ko-KR" altLang="en-US" sz="1600" dirty="0"/>
+              <a:rPr lang="ko-KR" altLang="en-US" sz="1600" dirty="0">
+                <a:latin typeface="나눔스퀘어_ac" panose="020B0600000101010101" pitchFamily="50" charset="-127"/>
+                <a:ea typeface="나눔스퀘어_ac" panose="020B0600000101010101" pitchFamily="50" charset="-127"/>
+              </a:rPr>
               <a:t>대시보드용으로 데이터 가공</a:t>
             </a:r>
           </a:p>
@@ -11180,7 +11442,7 @@
         <p:spPr>
           <a:xfrm>
             <a:off x="6470000" y="2721691"/>
-            <a:ext cx="4865434" cy="584775"/>
+            <a:ext cx="4221027" cy="584775"/>
           </a:xfrm>
           <a:prstGeom prst="rect">
             <a:avLst/>
@@ -11194,48 +11456,81 @@
           <a:lstStyle/>
           <a:p>
             <a:r>
-              <a:rPr lang="ko-KR" altLang="en-US" sz="1600" dirty="0"/>
+              <a:rPr lang="ko-KR" altLang="en-US" sz="1600" dirty="0">
+                <a:latin typeface="나눔스퀘어_ac" panose="020B0600000101010101" pitchFamily="50" charset="-127"/>
+                <a:ea typeface="나눔스퀘어_ac" panose="020B0600000101010101" pitchFamily="50" charset="-127"/>
+              </a:rPr>
               <a:t>지도 표시 데이터 생성</a:t>
             </a:r>
             <a:r>
-              <a:rPr lang="en-US" altLang="ko-KR" sz="1600" dirty="0"/>
+              <a:rPr lang="en-US" altLang="ko-KR" sz="1600" dirty="0">
+                <a:latin typeface="나눔스퀘어_ac" panose="020B0600000101010101" pitchFamily="50" charset="-127"/>
+                <a:ea typeface="나눔스퀘어_ac" panose="020B0600000101010101" pitchFamily="50" charset="-127"/>
+              </a:rPr>
               <a:t>, Target</a:t>
             </a:r>
             <a:r>
-              <a:rPr lang="ko-KR" altLang="en-US" sz="1600" dirty="0"/>
+              <a:rPr lang="ko-KR" altLang="en-US" sz="1600" dirty="0">
+                <a:latin typeface="나눔스퀘어_ac" panose="020B0600000101010101" pitchFamily="50" charset="-127"/>
+                <a:ea typeface="나눔스퀘어_ac" panose="020B0600000101010101" pitchFamily="50" charset="-127"/>
+              </a:rPr>
               <a:t>별 로그 그룹화</a:t>
             </a:r>
             <a:r>
-              <a:rPr lang="en-US" altLang="ko-KR" sz="1600" dirty="0"/>
+              <a:rPr lang="en-US" altLang="ko-KR" sz="1600" dirty="0">
+                <a:latin typeface="나눔스퀘어_ac" panose="020B0600000101010101" pitchFamily="50" charset="-127"/>
+                <a:ea typeface="나눔스퀘어_ac" panose="020B0600000101010101" pitchFamily="50" charset="-127"/>
+              </a:rPr>
               <a:t>, </a:t>
             </a:r>
           </a:p>
           <a:p>
             <a:r>
-              <a:rPr lang="ko-KR" altLang="en-US" sz="1600" dirty="0" err="1"/>
+              <a:rPr lang="ko-KR" altLang="en-US" sz="1600" dirty="0" err="1">
+                <a:latin typeface="나눔스퀘어_ac" panose="020B0600000101010101" pitchFamily="50" charset="-127"/>
+                <a:ea typeface="나눔스퀘어_ac" panose="020B0600000101010101" pitchFamily="50" charset="-127"/>
+              </a:rPr>
               <a:t>사람별</a:t>
             </a:r>
             <a:r>
-              <a:rPr lang="ko-KR" altLang="en-US" sz="1600" dirty="0"/>
+              <a:rPr lang="ko-KR" altLang="en-US" sz="1600" dirty="0">
+                <a:latin typeface="나눔스퀘어_ac" panose="020B0600000101010101" pitchFamily="50" charset="-127"/>
+                <a:ea typeface="나눔스퀘어_ac" panose="020B0600000101010101" pitchFamily="50" charset="-127"/>
+              </a:rPr>
               <a:t> 이동 경로 생성</a:t>
             </a:r>
             <a:r>
-              <a:rPr lang="en-US" altLang="ko-KR" sz="1600" dirty="0"/>
+              <a:rPr lang="en-US" altLang="ko-KR" sz="1600" dirty="0">
+                <a:latin typeface="나눔스퀘어_ac" panose="020B0600000101010101" pitchFamily="50" charset="-127"/>
+                <a:ea typeface="나눔스퀘어_ac" panose="020B0600000101010101" pitchFamily="50" charset="-127"/>
+              </a:rPr>
               <a:t>, </a:t>
             </a:r>
             <a:r>
-              <a:rPr lang="ko-KR" altLang="en-US" sz="1600" dirty="0"/>
+              <a:rPr lang="ko-KR" altLang="en-US" sz="1600" dirty="0">
+                <a:latin typeface="나눔스퀘어_ac" panose="020B0600000101010101" pitchFamily="50" charset="-127"/>
+                <a:ea typeface="나눔스퀘어_ac" panose="020B0600000101010101" pitchFamily="50" charset="-127"/>
+              </a:rPr>
               <a:t>최신 위치 추출</a:t>
             </a:r>
             <a:r>
-              <a:rPr lang="en-US" altLang="ko-KR" sz="1600" dirty="0"/>
+              <a:rPr lang="en-US" altLang="ko-KR" sz="1600" dirty="0">
+                <a:latin typeface="나눔스퀘어_ac" panose="020B0600000101010101" pitchFamily="50" charset="-127"/>
+                <a:ea typeface="나눔스퀘어_ac" panose="020B0600000101010101" pitchFamily="50" charset="-127"/>
+              </a:rPr>
               <a:t>, </a:t>
             </a:r>
             <a:r>
-              <a:rPr lang="ko-KR" altLang="en-US" sz="1600" dirty="0"/>
+              <a:rPr lang="ko-KR" altLang="en-US" sz="1600" dirty="0">
+                <a:latin typeface="나눔스퀘어_ac" panose="020B0600000101010101" pitchFamily="50" charset="-127"/>
+                <a:ea typeface="나눔스퀘어_ac" panose="020B0600000101010101" pitchFamily="50" charset="-127"/>
+              </a:rPr>
               <a:t>로그 샘플링</a:t>
             </a:r>
-            <a:endParaRPr lang="en-US" altLang="ko-KR" sz="1600" dirty="0"/>
+            <a:endParaRPr lang="en-US" altLang="ko-KR" sz="1600" dirty="0">
+              <a:latin typeface="나눔스퀘어_ac" panose="020B0600000101010101" pitchFamily="50" charset="-127"/>
+              <a:ea typeface="나눔스퀘어_ac" panose="020B0600000101010101" pitchFamily="50" charset="-127"/>
+            </a:endParaRPr>
           </a:p>
         </p:txBody>
       </p:sp>
@@ -11329,7 +11624,7 @@
         <p:spPr>
           <a:xfrm>
             <a:off x="6467367" y="4923891"/>
-            <a:ext cx="4374916" cy="584775"/>
+            <a:ext cx="3820277" cy="584775"/>
           </a:xfrm>
           <a:prstGeom prst="rect">
             <a:avLst/>
@@ -11343,53 +11638,89 @@
           <a:lstStyle/>
           <a:p>
             <a:r>
-              <a:rPr lang="ko-KR" altLang="en-US" sz="1600" dirty="0" err="1"/>
+              <a:rPr lang="ko-KR" altLang="en-US" sz="1600" dirty="0" err="1">
+                <a:latin typeface="나눔스퀘어_ac" panose="020B0600000101010101" pitchFamily="50" charset="-127"/>
+                <a:ea typeface="나눔스퀘어_ac" panose="020B0600000101010101" pitchFamily="50" charset="-127"/>
+              </a:rPr>
               <a:t>카카오맵</a:t>
             </a:r>
             <a:r>
-              <a:rPr lang="ko-KR" altLang="en-US" sz="1600" dirty="0"/>
+              <a:rPr lang="ko-KR" altLang="en-US" sz="1600" dirty="0">
+                <a:latin typeface="나눔스퀘어_ac" panose="020B0600000101010101" pitchFamily="50" charset="-127"/>
+                <a:ea typeface="나눔스퀘어_ac" panose="020B0600000101010101" pitchFamily="50" charset="-127"/>
+              </a:rPr>
               <a:t> 렌더링</a:t>
             </a:r>
             <a:r>
-              <a:rPr lang="en-US" altLang="ko-KR" sz="1600" dirty="0"/>
+              <a:rPr lang="en-US" altLang="ko-KR" sz="1600" dirty="0">
+                <a:latin typeface="나눔스퀘어_ac" panose="020B0600000101010101" pitchFamily="50" charset="-127"/>
+                <a:ea typeface="나눔스퀘어_ac" panose="020B0600000101010101" pitchFamily="50" charset="-127"/>
+              </a:rPr>
               <a:t>, </a:t>
             </a:r>
             <a:r>
-              <a:rPr lang="ko-KR" altLang="en-US" sz="1600" dirty="0"/>
+              <a:rPr lang="ko-KR" altLang="en-US" sz="1600" dirty="0">
+                <a:latin typeface="나눔스퀘어_ac" panose="020B0600000101010101" pitchFamily="50" charset="-127"/>
+                <a:ea typeface="나눔스퀘어_ac" panose="020B0600000101010101" pitchFamily="50" charset="-127"/>
+              </a:rPr>
               <a:t>지도 </a:t>
             </a:r>
             <a:r>
-              <a:rPr lang="en-US" altLang="ko-KR" sz="1600" dirty="0"/>
+              <a:rPr lang="en-US" altLang="ko-KR" sz="1600" dirty="0">
+                <a:latin typeface="나눔스퀘어_ac" panose="020B0600000101010101" pitchFamily="50" charset="-127"/>
+                <a:ea typeface="나눔스퀘어_ac" panose="020B0600000101010101" pitchFamily="50" charset="-127"/>
+              </a:rPr>
               <a:t>API </a:t>
             </a:r>
             <a:r>
-              <a:rPr lang="ko-KR" altLang="en-US" sz="1600" dirty="0"/>
+              <a:rPr lang="ko-KR" altLang="en-US" sz="1600" dirty="0">
+                <a:latin typeface="나눔스퀘어_ac" panose="020B0600000101010101" pitchFamily="50" charset="-127"/>
+                <a:ea typeface="나눔스퀘어_ac" panose="020B0600000101010101" pitchFamily="50" charset="-127"/>
+              </a:rPr>
               <a:t>초기화</a:t>
             </a:r>
             <a:r>
-              <a:rPr lang="en-US" altLang="ko-KR" sz="1600" dirty="0"/>
+              <a:rPr lang="en-US" altLang="ko-KR" sz="1600" dirty="0">
+                <a:latin typeface="나눔스퀘어_ac" panose="020B0600000101010101" pitchFamily="50" charset="-127"/>
+                <a:ea typeface="나눔스퀘어_ac" panose="020B0600000101010101" pitchFamily="50" charset="-127"/>
+              </a:rPr>
               <a:t>, </a:t>
             </a:r>
             <a:r>
-              <a:rPr lang="ko-KR" altLang="en-US" sz="1600" dirty="0"/>
+              <a:rPr lang="ko-KR" altLang="en-US" sz="1600" dirty="0">
+                <a:latin typeface="나눔스퀘어_ac" panose="020B0600000101010101" pitchFamily="50" charset="-127"/>
+                <a:ea typeface="나눔스퀘어_ac" panose="020B0600000101010101" pitchFamily="50" charset="-127"/>
+              </a:rPr>
               <a:t>예외 처리</a:t>
             </a:r>
             <a:r>
-              <a:rPr lang="en-US" altLang="ko-KR" sz="1600" dirty="0"/>
+              <a:rPr lang="en-US" altLang="ko-KR" sz="1600" dirty="0">
+                <a:latin typeface="나눔스퀘어_ac" panose="020B0600000101010101" pitchFamily="50" charset="-127"/>
+                <a:ea typeface="나눔스퀘어_ac" panose="020B0600000101010101" pitchFamily="50" charset="-127"/>
+              </a:rPr>
               <a:t>, </a:t>
             </a:r>
           </a:p>
           <a:p>
             <a:r>
-              <a:rPr lang="ko-KR" altLang="en-US" sz="1600" dirty="0"/>
+              <a:rPr lang="ko-KR" altLang="en-US" sz="1600" dirty="0">
+                <a:latin typeface="나눔스퀘어_ac" panose="020B0600000101010101" pitchFamily="50" charset="-127"/>
+                <a:ea typeface="나눔스퀘어_ac" panose="020B0600000101010101" pitchFamily="50" charset="-127"/>
+              </a:rPr>
               <a:t>렌더링 옵션 적용 </a:t>
             </a:r>
             <a:r>
-              <a:rPr lang="en-US" altLang="ko-KR" sz="1600" dirty="0"/>
+              <a:rPr lang="en-US" altLang="ko-KR" sz="1600" dirty="0">
+                <a:latin typeface="나눔스퀘어_ac" panose="020B0600000101010101" pitchFamily="50" charset="-127"/>
+                <a:ea typeface="나눔스퀘어_ac" panose="020B0600000101010101" pitchFamily="50" charset="-127"/>
+              </a:rPr>
               <a:t>&gt; </a:t>
             </a:r>
             <a:r>
-              <a:rPr lang="ko-KR" altLang="en-US" sz="1600" dirty="0"/>
+              <a:rPr lang="ko-KR" altLang="en-US" sz="1600" dirty="0">
+                <a:latin typeface="나눔스퀘어_ac" panose="020B0600000101010101" pitchFamily="50" charset="-127"/>
+                <a:ea typeface="나눔스퀘어_ac" panose="020B0600000101010101" pitchFamily="50" charset="-127"/>
+              </a:rPr>
               <a:t>자동 포커스 여부 설정</a:t>
             </a:r>
           </a:p>

</xml_diff>